<commit_message>
Lower minimum investment to $5,000 across portal, PDFs, and PPTX deck
</commit_message>
<xml_diff>
--- a/public/docs/investors/ATLAS_Investor_Pitch_Deck.pptx
+++ b/public/docs/investors/ATLAS_Investor_Pitch_Deck.pptx
@@ -3215,7 +3215,7 @@
               </a:defRPr>
             </a:pPr>
             <a:r>
-              <a:t>Target Capital: $75,000 USD (YC Post-Money SAFE)  |  Valuation Cap: $1,750,000 USD (~4.29% Equity Cap)</a:t>
+              <a:t>Target Capital: $75,000 USD (YC Post-Money SAFE)  |  Valuation Cap: $1,750,000 USD  |  Min Check: $5,000</a:t>
             </a:r>
           </a:p>
           <a:p>
@@ -7476,7 +7476,7 @@
               </a:defRPr>
             </a:pPr>
             <a:r>
-              <a:t>$10,000 Angel Ticket</a:t>
+              <a:t>$5,000 Minimum Ticket</a:t>
             </a:r>
           </a:p>
           <a:p>
@@ -7491,7 +7491,7 @@
               </a:defRPr>
             </a:pPr>
             <a:r>
-              <a:t>• Implied Equity Cap: ~0.57%</a:t>
+              <a:t>• Implied Equity Cap: ~0.29%</a:t>
             </a:r>
           </a:p>
           <a:p>
@@ -7506,7 +7506,7 @@
               </a:defRPr>
             </a:pPr>
             <a:r>
-              <a:t>• Seed Round Markup: $86k–$114k (8.6x–11.4x paper markup in 12–15 mos)</a:t>
+              <a:t>• Seed Round Markup: $43k–$57k (8.6x–11.4x paper markup in 12–15 mos)</a:t>
             </a:r>
           </a:p>
           <a:p>
@@ -7521,7 +7521,7 @@
               </a:defRPr>
             </a:pPr>
             <a:r>
-              <a:t>• Base Case M&amp;A (Yr 3 @ $79M): $450,000+ in cash (45.2x return)</a:t>
+              <a:t>• Mid-Market M&amp;A (Yr 3 @ $60M): $171,000 in cash (34.3x return)</a:t>
             </a:r>
           </a:p>
           <a:p>
@@ -7536,7 +7536,7 @@
               </a:defRPr>
             </a:pPr>
             <a:r>
-              <a:t>• Growth Case M&amp;A (Yr 4 @ $538M): $3.06 Million in cash (307x return)</a:t>
+              <a:t>• Scale Buyout (Yr 4–5 @ $175M): $500,000 in cash (100x return)</a:t>
             </a:r>
           </a:p>
           <a:p>
@@ -7551,7 +7551,7 @@
               </a:defRPr>
             </a:pPr>
             <a:r>
-              <a:t>• Annual Cash Dividend (Yr 3): ~$75,000 / year (746% annual cash yield)</a:t>
+              <a:t>• Annual Cash Dividend (Yr 3): ~$37,500 / year (750% annual cash yield)</a:t>
             </a:r>
           </a:p>
         </p:txBody>
@@ -7631,7 +7631,7 @@
               </a:defRPr>
             </a:pPr>
             <a:r>
-              <a:t>$25,000 Lead Syndicate Ticket</a:t>
+              <a:t>$25,000 Recommended Check</a:t>
             </a:r>
           </a:p>
           <a:p>
@@ -7661,7 +7661,7 @@
               </a:defRPr>
             </a:pPr>
             <a:r>
-              <a:t>• Seed Round Markup: $215k–$286k (8.6x–11.4x paper markup)</a:t>
+              <a:t>• Seed Round Markup: $214k–$286k (8.6x–11.4x paper markup)</a:t>
             </a:r>
           </a:p>
           <a:p>
@@ -7676,7 +7676,7 @@
               </a:defRPr>
             </a:pPr>
             <a:r>
-              <a:t>• Base Case M&amp;A (Yr 3 @ $79M): $1.13 Million in cash (45.2x return)</a:t>
+              <a:t>• Mid-Market M&amp;A (Yr 3 @ $60M): $857,000 in cash (34.3x return)</a:t>
             </a:r>
           </a:p>
           <a:p>
@@ -7691,7 +7691,7 @@
               </a:defRPr>
             </a:pPr>
             <a:r>
-              <a:t>• Growth Case M&amp;A (Yr 4 @ $538M): $7.68 Million in cash (307x return)</a:t>
+              <a:t>• Scale Buyout (Yr 4–5 @ $175M): $2.50 Million in cash (100x return)</a:t>
             </a:r>
           </a:p>
           <a:p>
@@ -7706,7 +7706,7 @@
               </a:defRPr>
             </a:pPr>
             <a:r>
-              <a:t>• Annual Cash Dividend (Yr 3): ~$187,000 / year (749% annual cash yield)</a:t>
+              <a:t>• Annual Cash Dividend (Yr 3): ~$187,500 / year (750% annual cash yield)</a:t>
             </a:r>
           </a:p>
         </p:txBody>
@@ -7816,7 +7816,7 @@
               </a:defRPr>
             </a:pPr>
             <a:r>
-              <a:t>• Seed Round Markup: $644k–$858k (8.6x–11.4x paper markup)</a:t>
+              <a:t>• Seed Round Markup: $643k–$857k (8.6x–11.4x paper markup)</a:t>
             </a:r>
           </a:p>
           <a:p>
@@ -7831,7 +7831,7 @@
               </a:defRPr>
             </a:pPr>
             <a:r>
-              <a:t>• Base Case M&amp;A (Yr 3 @ $79M): $3.39 Million in cash (45.2x return)</a:t>
+              <a:t>• Mid-Market M&amp;A (Yr 3 @ $60M): $2.57 Million in cash (34.3x return)</a:t>
             </a:r>
           </a:p>
           <a:p>
@@ -7846,7 +7846,7 @@
               </a:defRPr>
             </a:pPr>
             <a:r>
-              <a:t>• Growth Case M&amp;A (Yr 4 @ $538M): $23.06 Million in cash (307x return)</a:t>
+              <a:t>• Scale Buyout (Yr 4–5 @ $175M): $7.50 Million in cash (100x return)</a:t>
             </a:r>
           </a:p>
           <a:p>
@@ -7861,7 +7861,7 @@
               </a:defRPr>
             </a:pPr>
             <a:r>
-              <a:t>• Annual Cash Dividend (Yr 3): ~$562,000 / year (749% annual cash yield)</a:t>
+              <a:t>• Annual Cash Dividend (Yr 3): ~$562,500 / year (750% annual cash yield)</a:t>
             </a:r>
           </a:p>
         </p:txBody>

</xml_diff>